<commit_message>
Clarify reproduction guides and clean figure metadata
Refine public descriptions and command-line help while preserving scientific computations and results.

Remove maintenance notes from editable figures, clarify S13 source and download roles, and synchronize artifact and assembly checksums.
</commit_message>
<xml_diff>
--- a/figures/assembly/suppfig13/supfig13.pptx
+++ b/figures/assembly/suppfig13/supfig13.pptx
@@ -297,52 +297,52 @@
           <a:lstStyle/>
           <a:p>
             <a:r>
-              <a:t>Supplemental Figure 13: TIvelo root-dependent trajectory orientation.</a:t>
-            </a:r>
-          </a:p>
-          <a:p>
-            <a:r>
-              <a:t>Template: /Users/tomorin/Desktop/pdf_new/supfig12.pptx; original slide canvas and Arial panel labels retained.</a:t>
-            </a:r>
-          </a:p>
-          <a:p>
-            <a:r>
-              <a:t>A/B: frozen stage-tracing simulation materials. C: separate original-root vs known-early-root paired refits.</a:t>
-            </a:r>
-          </a:p>
-          <a:p>
-            <a:r>
-              <a:t>D: actual native full-data DPT, not Palantir pseudotime; identical bone-marrow t-SNE coordinates; three paired optimizer seeds.</a:t>
-            </a:r>
-          </a:p>
-          <a:p>
-            <a:r>
-              <a:t>Simulation root states: /Users/tomorin/Desktop/tivelo_gene_ABC_selected_20260930/assembly_preview_20261001/redesign_v3/ab_assets/state_selection_material.png</a:t>
-            </a:r>
-          </a:p>
-          <a:p>
-            <a:r>
-              <a:t>Known bins and path-wise DPT: /Users/tomorin/Desktop/tivelo_gene_ABC_selected_20260930/assembly_preview_20261001/redesign_v3/ab_assets/order_comparison_material.png</a:t>
-            </a:r>
-          </a:p>
-          <a:p>
-            <a:r>
-              <a:t>Paired simulation gene metrics: /Users/tomorin/Desktop/tivelo_gene_ABC_selected_20260930/assembly_preview_20261001/redesign_v3/tivelo_root_control_gene_metrics.png</a:t>
-            </a:r>
-          </a:p>
-          <a:p>
-            <a:r>
-              <a:t>Bone marrow global DPT and paired cell metrics: /Users/tomorin/Desktop/tivelo_gene_ABC_selected_20260930/assembly_preview_20261001/redesign_v3/bonemarrow_root_control_row.png</a:t>
-            </a:r>
-          </a:p>
-          <a:p>
-            <a:r>
-              <a:t>Existing plot assets embedded without regenerating data or adding a figure caption.</a:t>
-            </a:r>
-          </a:p>
-          <a:p>
-            <a:r>
-              <a:t>A/B updated from approved compact material: one unlabeled shared 0--1 colorbar at bottom right. Top row normal + branching; bottom row hybrid. Known bins divided by 9; path-wise DPT unchanged. All a/b/c/d labels are independent native text boxes. C/D source images and placements unchanged.</a:t>
+              <a:t/>
+            </a:r>
+          </a:p>
+          <a:p>
+            <a:r>
+              <a:t/>
+            </a:r>
+          </a:p>
+          <a:p>
+            <a:r>
+              <a:t/>
+            </a:r>
+          </a:p>
+          <a:p>
+            <a:r>
+              <a:t/>
+            </a:r>
+          </a:p>
+          <a:p>
+            <a:r>
+              <a:t/>
+            </a:r>
+          </a:p>
+          <a:p>
+            <a:r>
+              <a:t/>
+            </a:r>
+          </a:p>
+          <a:p>
+            <a:r>
+              <a:t/>
+            </a:r>
+          </a:p>
+          <a:p>
+            <a:r>
+              <a:t/>
+            </a:r>
+          </a:p>
+          <a:p>
+            <a:r>
+              <a:t/>
+            </a:r>
+          </a:p>
+          <a:p>
+            <a:r>
+              <a:t/>
             </a:r>
           </a:p>
         </p:txBody>

</xml_diff>